<commit_message>
pm-method 2.7.0: portal unificado de pm-kb (tableros con historial congelado en cada puerta, tarjetas-enlace, artefactos, enlaces compartidos y tableros por actor)
</commit_message>
<xml_diff>
--- a/docs/webinar/E2E-1/E2E-1-diapositivas.pptx
+++ b/docs/webinar/E2E-1/E2E-1-diapositivas.pptx
@@ -152,12 +152,12 @@
   <p:extLst>
     <p:ext uri="{521415D9-36F7-43E2-AB2F-B90AF26B5E84}">
       <p14:sectionLst xmlns:p14="http://schemas.microsoft.com/office/powerpoint/2010/main">
-        <p14:section name="Portada" id="{7796ab51-2e99-f3ec-9763-1cdfbd5b4f74}">
+        <p14:section name="Portada" id="{11cad022-8c2f-01d3-2d19-609dcccbccaa}">
           <p14:sldIdLst>
             <p14:sldId id="256"/>
           </p14:sldIdLst>
         </p14:section>
-        <p14:section name="Clase 1 · Del taller al plan de respuesta" id="{fbdfc4dc-45d6-a5ef-100a-dc7e22b0a71b}">
+        <p14:section name="Clase 1 · Del taller al plan de respuesta" id="{0494d901-c553-f06a-6399-bd31e6310e60}">
           <p14:sldIdLst>
             <p14:sldId id="257"/>
             <p14:sldId id="258"/>
@@ -182,7 +182,7 @@
             <p14:sldId id="277"/>
           </p14:sldIdLst>
         </p14:section>
-        <p14:section name="Clase 2 · El control continuo" id="{89b37457-312f-7d95-3313-53e881f6b0a7}">
+        <p14:section name="Clase 2 · El control continuo" id="{991710aa-6c98-88dd-6bca-de132919e274}">
           <p14:sldIdLst>
             <p14:sldId id="278"/>
             <p14:sldId id="279"/>
@@ -207,7 +207,7 @@
             <p14:sldId id="298"/>
           </p14:sldIdLst>
         </p14:section>
-        <p14:section name="Glosario" id="{cbd5073d-e131-364d-d3b8-b1a9d5c7890e}">
+        <p14:section name="Glosario" id="{6f6f11e4-1bb6-eb70-0c5c-5884193aa40d}">
           <p14:sldIdLst>
             <p14:sldId id="299"/>
             <p14:sldId id="300"/>
@@ -4809,7 +4809,7 @@
                   <a:srgbClr val="D6E4F0"/>
                 </a:solidFill>
               </a:rPr>
-              <a:t>pm-method 2.6.0 · Webinar E2E-1 · Clase 1</a:t>
+              <a:t>pm-method 2.7.0 · Webinar E2E-1 · Clase 1</a:t>
             </a:r>
             <a:endParaRPr lang="en-US" sz="1000" dirty="0"/>
           </a:p>
@@ -5049,7 +5049,7 @@
                   <a:srgbClr val="696969"/>
                 </a:solidFill>
               </a:rPr>
-              <a:t>pm-method 2.6.0 · Webinar E2E-1 · Clase 2</a:t>
+              <a:t>pm-method 2.7.0 · Webinar E2E-1 · Clase 2</a:t>
             </a:r>
             <a:endParaRPr lang="en-US" sz="1000" dirty="0"/>
           </a:p>
@@ -5267,7 +5267,7 @@
                   <a:srgbClr val="D6E4F0"/>
                 </a:solidFill>
               </a:rPr>
-              <a:t>pm-method 2.6.0 · Webinar E2E-1 · Clase 2</a:t>
+              <a:t>pm-method 2.7.0 · Webinar E2E-1 · Clase 2</a:t>
             </a:r>
             <a:endParaRPr lang="en-US" sz="1000" dirty="0"/>
           </a:p>
@@ -5485,7 +5485,7 @@
                   <a:srgbClr val="D6E4F0"/>
                 </a:solidFill>
               </a:rPr>
-              <a:t>pm-method 2.6.0 · Webinar E2E-1 · Clase 2</a:t>
+              <a:t>pm-method 2.7.0 · Webinar E2E-1 · Clase 2</a:t>
             </a:r>
             <a:endParaRPr lang="en-US" sz="1000" dirty="0"/>
           </a:p>
@@ -5703,7 +5703,7 @@
                   <a:srgbClr val="D6E4F0"/>
                 </a:solidFill>
               </a:rPr>
-              <a:t>pm-method 2.6.0 · Webinar E2E-1 · Clase 2</a:t>
+              <a:t>pm-method 2.7.0 · Webinar E2E-1 · Clase 2</a:t>
             </a:r>
             <a:endParaRPr lang="en-US" sz="1000" dirty="0"/>
           </a:p>
@@ -5879,7 +5879,7 @@
                   <a:srgbClr val="D6E4F0"/>
                 </a:solidFill>
               </a:rPr>
-              <a:t>pm-method 2.6.0 · Webinar E2E-1</a:t>
+              <a:t>pm-method 2.7.0 · Webinar E2E-1</a:t>
             </a:r>
             <a:endParaRPr lang="en-US" sz="1000" dirty="0"/>
           </a:p>
@@ -6074,7 +6074,7 @@
                   <a:srgbClr val="696969"/>
                 </a:solidFill>
               </a:rPr>
-              <a:t>pm-method 2.6.0 · Webinar E2E-1</a:t>
+              <a:t>pm-method 2.7.0 · Webinar E2E-1</a:t>
             </a:r>
             <a:endParaRPr lang="en-US" sz="1000" dirty="0"/>
           </a:p>
@@ -6292,7 +6292,7 @@
                   <a:srgbClr val="D6E4F0"/>
                 </a:solidFill>
               </a:rPr>
-              <a:t>pm-method 2.6.0 · Webinar E2E-1</a:t>
+              <a:t>pm-method 2.7.0 · Webinar E2E-1</a:t>
             </a:r>
             <a:endParaRPr lang="en-US" sz="1000" dirty="0"/>
           </a:p>
@@ -6510,7 +6510,7 @@
                   <a:srgbClr val="D6E4F0"/>
                 </a:solidFill>
               </a:rPr>
-              <a:t>pm-method 2.6.0 · Webinar E2E-1</a:t>
+              <a:t>pm-method 2.7.0 · Webinar E2E-1</a:t>
             </a:r>
             <a:endParaRPr lang="en-US" sz="1000" dirty="0"/>
           </a:p>
@@ -6728,7 +6728,7 @@
                   <a:srgbClr val="D6E4F0"/>
                 </a:solidFill>
               </a:rPr>
-              <a:t>pm-method 2.6.0 · Webinar E2E-1</a:t>
+              <a:t>pm-method 2.7.0 · Webinar E2E-1</a:t>
             </a:r>
             <a:endParaRPr lang="en-US" sz="1000" dirty="0"/>
           </a:p>
@@ -6968,7 +6968,7 @@
                   <a:srgbClr val="696969"/>
                 </a:solidFill>
               </a:rPr>
-              <a:t>pm-method 2.6.0 · Webinar E2E-1 · Clase 1</a:t>
+              <a:t>pm-method 2.7.0 · Webinar E2E-1 · Clase 1</a:t>
             </a:r>
             <a:endParaRPr lang="en-US" sz="1000" dirty="0"/>
           </a:p>
@@ -7186,7 +7186,7 @@
                   <a:srgbClr val="D6E4F0"/>
                 </a:solidFill>
               </a:rPr>
-              <a:t>pm-method 2.6.0 · Webinar E2E-1 · Clase 1</a:t>
+              <a:t>pm-method 2.7.0 · Webinar E2E-1 · Clase 1</a:t>
             </a:r>
             <a:endParaRPr lang="en-US" sz="1000" dirty="0"/>
           </a:p>
@@ -7404,7 +7404,7 @@
                   <a:srgbClr val="D6E4F0"/>
                 </a:solidFill>
               </a:rPr>
-              <a:t>pm-method 2.6.0 · Webinar E2E-1 · Clase 1</a:t>
+              <a:t>pm-method 2.7.0 · Webinar E2E-1 · Clase 1</a:t>
             </a:r>
             <a:endParaRPr lang="en-US" sz="1000" dirty="0"/>
           </a:p>
@@ -7848,7 +7848,7 @@
                 <a:ea typeface="Arial" pitchFamily="34" charset="-122"/>
                 <a:cs typeface="Arial" pitchFamily="34" charset="-120"/>
               </a:rPr>
-              <a:t>Webinar · pm-method 2.6.0 · E2E-1</a:t>
+              <a:t>Webinar · pm-method 2.7.0 · E2E-1</a:t>
             </a:r>
             <a:endParaRPr lang="en-US" sz="1600" dirty="0"/>
           </a:p>

</xml_diff>